<commit_message>
Update notebook, report and deck to final wording
Brings the deliverables to their final October 2026 state: readable chart labels, the PowerPoint chart-label fix, and two rounds of wording fixes so every claim matches what the analysis supports (for example, the adjusted gap is reported as no significant difference, not proof of fairness). Adds a PDF of the deck and a README with method, findings, limitations and project history.

Co-Authored-By: Claude Opus 5.5 <noreply@anthropic.com>
Claude-Session: https://claude.ai/code/session_0189oixY1HgZzrPqKf2HyBjs
</commit_message>
<xml_diff>
--- a/Workplace_Diversity_Analysis_Deck.pptx
+++ b/Workplace_Diversity_Analysis_Deck.pptx
@@ -1610,7 +1610,7 @@
                 </a:solidFill>
                 <a:latin typeface="Calibri"/>
               </a:rPr>
-              <a:t>Average years of experience to reach each level</a:t>
+              <a:t>Average years of experience at each level</a:t>
             </a:r>
           </a:p>
         </c:rich>
@@ -3996,7 +3996,7 @@
                 <a:ea typeface="Calibri" pitchFamily="34" charset="-122"/>
                 <a:cs typeface="Calibri" pitchFamily="34" charset="-120"/>
               </a:rPr>
-              <a:t>The comp model looks fair — but that finding can mask a structural issue: who gets into which department, and who gets promoted.</a:t>
+              <a:t>The model finds no significant gap within level and department — not proof of fairness (no performance control). It can mask who gets into which department and who gets promoted.</a:t>
             </a:r>
             <a:endParaRPr lang="en-US" sz="1250" dirty="0"/>
           </a:p>
@@ -4654,7 +4654,7 @@
                 <a:ea typeface="Cambria" pitchFamily="34" charset="-122"/>
                 <a:cs typeface="Cambria" pitchFamily="34" charset="-120"/>
               </a:rPr>
-              <a:t>Pay is fair for equal roles. Representation and promotion speed are where the company should focus next.</a:t>
+              <a:t>No significant pay gap within level and department. Representation and promotion speed are where to look next.</a:t>
             </a:r>
             <a:endParaRPr lang="en-US" sz="2800" dirty="0"/>
           </a:p>
@@ -4803,7 +4803,7 @@
                 <a:ea typeface="Calibri" pitchFamily="34" charset="-122"/>
                 <a:cs typeface="Calibri" pitchFamily="34" charset="-120"/>
               </a:rPr>
-              <a:t>There is a real 14% pay gap between men and women. But it isn't a same-job pay problem — it's a representation and promotion problem that shows up downstream as a pay gap.</a:t>
+              <a:t>There is a real 14% pay gap between men and women. We find no significant gap within the same level and department — the pattern points to representation and promotion differences that show up downstream as a pay gap.</a:t>
             </a:r>
             <a:endParaRPr lang="en-US" sz="1600" dirty="0"/>
           </a:p>
@@ -5135,7 +5135,7 @@
                 <a:ea typeface="Calibri" pitchFamily="34" charset="-122"/>
                 <a:cs typeface="Calibri" pitchFamily="34" charset="-120"/>
               </a:rPr>
-              <a:t>Not significant, p = 0.65 — pay is fair for equal roles</a:t>
+              <a:t>Not significant, p = 0.65 — no significant gap within the same level and department (no performance control)</a:t>
             </a:r>
             <a:endParaRPr lang="en-US" sz="1150" dirty="0"/>
           </a:p>
@@ -5262,7 +5262,7 @@
                 <a:ea typeface="Calibri" pitchFamily="34" charset="-122"/>
                 <a:cs typeface="Calibri" pitchFamily="34" charset="-120"/>
               </a:rPr>
-              <a:t>Women vs. men in Engineering</a:t>
+              <a:t>Share of women vs. men working in Engineering</a:t>
             </a:r>
             <a:endParaRPr lang="en-US" sz="1400" dirty="0"/>
           </a:p>
@@ -5783,7 +5783,7 @@
                 <a:ea typeface="Calibri" pitchFamily="34" charset="-122"/>
                 <a:cs typeface="Calibri" pitchFamily="34" charset="-120"/>
               </a:rPr>
-              <a:t>Implemented directly in numpy (no internet access for scikit-learn/statsmodels in this environment); significance from the normal approximation, accurate at n ≈ 10,000.</a:t>
+              <a:t>OLS implemented directly in NumPy; significance from the normal approximation, accurate at n ≈ 10,000.</a:t>
             </a:r>
             <a:endParaRPr lang="en-US" sz="1200" dirty="0"/>
           </a:p>
@@ -5920,7 +5920,7 @@
                 <a:ea typeface="Calibri" pitchFamily="34" charset="-122"/>
                 <a:cs typeface="Calibri" pitchFamily="34" charset="-120"/>
               </a:rPr>
-              <a:t>Compared raw pay gaps to gaps after controlling for level, department, degree, experience, and tenure.</a:t>
+              <a:t>Compared raw pay gaps to gaps after controlling for level, department, degree, experience, and signing bonus.</a:t>
             </a:r>
             <a:endParaRPr lang="en-US" sz="1200" dirty="0"/>
           </a:p>
@@ -6030,7 +6030,7 @@
                 <a:ea typeface="Calibri" pitchFamily="34" charset="-122"/>
                 <a:cs typeface="Calibri" pitchFamily="34" charset="-120"/>
               </a:rPr>
-              <a:t>Share of the 10,000-person company at each level</a:t>
+              <a:t>Share of the 10,000-person company at each level (bar not to scale)</a:t>
             </a:r>
             <a:endParaRPr lang="en-US" sz="1400" dirty="0"/>
           </a:p>
@@ -8590,7 +8590,7 @@
                 <a:ea typeface="Calibri" pitchFamily="34" charset="-122"/>
                 <a:cs typeface="Calibri" pitchFamily="34" charset="-120"/>
               </a:rPr>
-              <a:t>Level and department dominate; tenure, degree, and signing bonus barely matter</a:t>
+              <a:t>Level and department dominate; experience, degree, and signing bonus show no significant effect</a:t>
             </a:r>
             <a:endParaRPr lang="en-US" sz="1400" dirty="0"/>
           </a:p>
@@ -9105,7 +9105,7 @@
                 <a:ea typeface="Calibri" pitchFamily="34" charset="-122"/>
                 <a:cs typeface="Calibri" pitchFamily="34" charset="-120"/>
               </a:rPr>
-              <a:t>Degree, tenure, signing bonus, and sex — all p ≥ 0.13. Sex in particular: p = 0.65.</a:t>
+              <a:t>Degree, experience, signing bonus, and sex — all p ≥ 0.13. Sex in particular: p = 0.65.</a:t>
             </a:r>
             <a:endParaRPr lang="en-US" sz="1100" dirty="0"/>
           </a:p>
@@ -9167,7 +9167,7 @@
                 <a:ea typeface="Calibri" pitchFamily="34" charset="-122"/>
                 <a:cs typeface="Calibri" pitchFamily="34" charset="-120"/>
               </a:rPr>
-              <a:t>Bottom line: level + department set pay. Once you're in a role, sex does not move the needle.</a:t>
+              <a:t>Bottom line: level and department set pay. With them held constant, sex has no significant effect.</a:t>
             </a:r>
             <a:endParaRPr lang="en-US" sz="1200" dirty="0"/>
           </a:p>
@@ -9603,7 +9603,7 @@
                 <a:ea typeface="Calibri" pitchFamily="34" charset="-122"/>
                 <a:cs typeface="Calibri" pitchFamily="34" charset="-120"/>
               </a:rPr>
-              <a:t>Women are concentrated in the lowest-paying department and scarce in the highest-paying one</a:t>
+              <a:t>A larger share of women than men work in the lowest-paying department, and a smaller share in the highest-paying one</a:t>
             </a:r>
             <a:endParaRPr lang="en-US" sz="1400" dirty="0"/>
           </a:p>
@@ -9719,7 +9719,7 @@
                 <a:ea typeface="Calibri" pitchFamily="34" charset="-122"/>
                 <a:cs typeface="Calibri" pitchFamily="34" charset="-120"/>
               </a:rPr>
-              <a:t>18.8% women  vs.  31.4% men</a:t>
+              <a:t>18.8% of women  vs.  31.4% of men</a:t>
             </a:r>
             <a:endParaRPr lang="en-US" sz="1300" dirty="0"/>
           </a:p>
@@ -9858,7 +9858,7 @@
                 <a:ea typeface="Calibri" pitchFamily="34" charset="-122"/>
                 <a:cs typeface="Calibri" pitchFamily="34" charset="-120"/>
               </a:rPr>
-              <a:t>29.7% women  vs.  9.9% men</a:t>
+              <a:t>29.7% of women  vs.  9.9% of men</a:t>
             </a:r>
             <a:endParaRPr lang="en-US" sz="1300" dirty="0"/>
           </a:p>
@@ -9968,7 +9968,7 @@
                 <a:ea typeface="Cambria" pitchFamily="34" charset="-122"/>
                 <a:cs typeface="Cambria" pitchFamily="34" charset="-120"/>
               </a:rPr>
-              <a:t>A Slower Path to the Top</a:t>
+              <a:t>Experience at Senior Levels</a:t>
             </a:r>
             <a:endParaRPr lang="en-US" sz="3000" dirty="0"/>
           </a:p>
@@ -10007,7 +10007,7 @@
                 <a:ea typeface="Calibri" pitchFamily="34" charset="-122"/>
                 <a:cs typeface="Calibri" pitchFamily="34" charset="-120"/>
               </a:rPr>
-              <a:t>Women who reach senior levels have needed more tenure to get there than men at the same level</a:t>
+              <a:t>Women at senior levels have more experience on average than men at the same level</a:t>
             </a:r>
             <a:endParaRPr lang="en-US" sz="1400" dirty="0"/>
           </a:p>
@@ -10162,7 +10162,7 @@
                 <a:ea typeface="Calibri" pitchFamily="34" charset="-122"/>
                 <a:cs typeface="Calibri" pitchFamily="34" charset="-120"/>
               </a:rPr>
-              <a:t>16.5 yrs (women)  vs.  12.9 yrs (men)</a:t>
+              <a:t>16.5 yrs (women)  vs.  12.9 yrs (men) (not significance-tested)</a:t>
             </a:r>
             <a:endParaRPr lang="en-US" sz="1300" dirty="0"/>
           </a:p>
@@ -10262,7 +10262,7 @@
                 <a:ea typeface="Calibri" pitchFamily="34" charset="-122"/>
                 <a:cs typeface="Calibri" pitchFamily="34" charset="-120"/>
               </a:rPr>
-              <a:t>25.6 yrs (women)  vs.  19.0 yrs (men)</a:t>
+              <a:t>25.6 yrs (women)  vs.  19.0 yrs (men) (not significance-tested)</a:t>
             </a:r>
             <a:endParaRPr lang="en-US" sz="1300" dirty="0"/>
           </a:p>
@@ -10301,7 +10301,7 @@
                 <a:ea typeface="Calibri" pitchFamily="34" charset="-122"/>
                 <a:cs typeface="Calibri" pitchFamily="34" charset="-120"/>
               </a:rPr>
-              <a:t>Women also hold only 1.60% of Director+ roles, vs. 2.21% for men (p = 0.038).</a:t>
+              <a:t>1.60% of women reach Director or above, vs. 2.21% of men (p = 0.038).</a:t>
             </a:r>
             <a:endParaRPr lang="en-US" sz="1150" dirty="0"/>
           </a:p>

</xml_diff>